<commit_message>
Rotate field layout 180 degrees so Amrit Sarovar is on the left
Co-Authored-By: Claude Opus 5.5 <noreply@anthropic.com>
Claude-Session: https://claude.ai/code/session_01CzZu6CZ8sezjwuGXKico4b
</commit_message>
<xml_diff>
--- a/field_layout/Field_Layout_30m_Buffer.pptx
+++ b/field_layout/Field_Layout_30m_Buffer.pptx
@@ -503,7 +503,7 @@
           <a:p>
             <a:r>
               <a:rPr lang="en-US" dirty="0"/>
-              <a:t>Drawn to scale (0.14 inch per metre). Plot numbers and treatments are unchanged from the original layout; only the 30 m buffer strip is added between R3 and the healthy block. The 0.5 m bund width is inferred from the original 48 m field width (12 plots x 3.5 m = 42 m plus 11 bunds).</a:t>
+              <a:t>Drawn to scale (0.14 inch per metre). Plot numbers and treatments are unchanged from the original layout; the layout is rotated 180 degrees (viewed from the opposite side) so Amrit Sarovar is on the left, and a 30 m buffer strip separates R3 from the healthy block. The 0.5 m bund width is inferred from the original 48 m field width (12 plots x 3.5 m = 42 m plus 11 bunds).</a:t>
             </a:r>
             <a:endParaRPr lang="en-US" dirty="0"/>
           </a:p>
@@ -1202,7 +1202,7 @@
                 <a:ea typeface="Cambria" pitchFamily="34" charset="-122"/>
                 <a:cs typeface="Cambria" pitchFamily="34" charset="-120"/>
               </a:rPr>
-              <a:t>Field layout with a 30 m buffer between inoculated and healthy plots</a:t>
+              <a:t>Field layout with 30 m buffer, Amrit Sarovar on the left</a:t>
             </a:r>
             <a:endParaRPr lang="en-US" sz="2800" dirty="0"/>
           </a:p>
@@ -1216,7 +1216,7 @@
         </p:nvSpPr>
         <p:spPr>
           <a:xfrm>
-            <a:off x="868680" y="1965960"/>
+            <a:off x="1600200" y="1874520"/>
             <a:ext cx="9857232" cy="3072384"/>
           </a:xfrm>
           <a:prstGeom prst="rect">
@@ -1241,7 +1241,7 @@
         </p:nvSpPr>
         <p:spPr>
           <a:xfrm>
-            <a:off x="5413248" y="1965960"/>
+            <a:off x="3072384" y="1874520"/>
             <a:ext cx="3840480" cy="3072384"/>
           </a:xfrm>
           <a:prstGeom prst="rect">
@@ -1266,7 +1266,7 @@
         </p:nvSpPr>
         <p:spPr>
           <a:xfrm>
-            <a:off x="868680" y="2606040"/>
+            <a:off x="1600200" y="4050792"/>
             <a:ext cx="9857232" cy="256032"/>
           </a:xfrm>
           <a:prstGeom prst="rect">
@@ -1291,7 +1291,7 @@
         </p:nvSpPr>
         <p:spPr>
           <a:xfrm>
-            <a:off x="868680" y="2606040"/>
+            <a:off x="6912864" y="4050792"/>
             <a:ext cx="4544568" cy="256032"/>
           </a:xfrm>
           <a:prstGeom prst="rect">
@@ -1330,7 +1330,7 @@
         </p:nvSpPr>
         <p:spPr>
           <a:xfrm>
-            <a:off x="9253728" y="2606040"/>
+            <a:off x="1600200" y="4050792"/>
             <a:ext cx="1472184" cy="256032"/>
           </a:xfrm>
           <a:prstGeom prst="rect">
@@ -1369,7 +1369,7 @@
         </p:nvSpPr>
         <p:spPr>
           <a:xfrm>
-            <a:off x="868680" y="4142232"/>
+            <a:off x="1600200" y="2514600"/>
             <a:ext cx="9857232" cy="256032"/>
           </a:xfrm>
           <a:prstGeom prst="rect">
@@ -1394,7 +1394,7 @@
         </p:nvSpPr>
         <p:spPr>
           <a:xfrm>
-            <a:off x="868680" y="4142232"/>
+            <a:off x="6912864" y="2514600"/>
             <a:ext cx="4544568" cy="256032"/>
           </a:xfrm>
           <a:prstGeom prst="rect">
@@ -1433,7 +1433,7 @@
         </p:nvSpPr>
         <p:spPr>
           <a:xfrm>
-            <a:off x="9253728" y="4142232"/>
+            <a:off x="1600200" y="2514600"/>
             <a:ext cx="1472184" cy="256032"/>
           </a:xfrm>
           <a:prstGeom prst="rect">
@@ -1472,7 +1472,7 @@
         </p:nvSpPr>
         <p:spPr>
           <a:xfrm>
-            <a:off x="5504688" y="2862072"/>
+            <a:off x="3163824" y="2770632"/>
             <a:ext cx="3657600" cy="1280160"/>
           </a:xfrm>
           <a:prstGeom prst="rect">
@@ -1562,7 +1562,7 @@
         </p:nvSpPr>
         <p:spPr>
           <a:xfrm>
-            <a:off x="868680" y="1965960"/>
+            <a:off x="11009376" y="4306824"/>
             <a:ext cx="448056" cy="640080"/>
           </a:xfrm>
           <a:prstGeom prst="rect">
@@ -1587,7 +1587,7 @@
         </p:nvSpPr>
         <p:spPr>
           <a:xfrm>
-            <a:off x="868680" y="1965960"/>
+            <a:off x="11009376" y="4306824"/>
             <a:ext cx="448056" cy="640080"/>
           </a:xfrm>
           <a:prstGeom prst="rect">
@@ -1643,7 +1643,7 @@
         </p:nvSpPr>
         <p:spPr>
           <a:xfrm>
-            <a:off x="1380744" y="1965960"/>
+            <a:off x="10497312" y="4306824"/>
             <a:ext cx="448056" cy="640080"/>
           </a:xfrm>
           <a:prstGeom prst="rect">
@@ -1668,7 +1668,7 @@
         </p:nvSpPr>
         <p:spPr>
           <a:xfrm>
-            <a:off x="1380744" y="1965960"/>
+            <a:off x="10497312" y="4306824"/>
             <a:ext cx="448056" cy="640080"/>
           </a:xfrm>
           <a:prstGeom prst="rect">
@@ -1724,7 +1724,7 @@
         </p:nvSpPr>
         <p:spPr>
           <a:xfrm>
-            <a:off x="1892808" y="1965960"/>
+            <a:off x="9985248" y="4306824"/>
             <a:ext cx="448056" cy="640080"/>
           </a:xfrm>
           <a:prstGeom prst="rect">
@@ -1749,7 +1749,7 @@
         </p:nvSpPr>
         <p:spPr>
           <a:xfrm>
-            <a:off x="1892808" y="1965960"/>
+            <a:off x="9985248" y="4306824"/>
             <a:ext cx="448056" cy="640080"/>
           </a:xfrm>
           <a:prstGeom prst="rect">
@@ -1805,7 +1805,7 @@
         </p:nvSpPr>
         <p:spPr>
           <a:xfrm>
-            <a:off x="2404872" y="1965960"/>
+            <a:off x="9473184" y="4306824"/>
             <a:ext cx="448056" cy="640080"/>
           </a:xfrm>
           <a:prstGeom prst="rect">
@@ -1830,7 +1830,7 @@
         </p:nvSpPr>
         <p:spPr>
           <a:xfrm>
-            <a:off x="2404872" y="1965960"/>
+            <a:off x="9473184" y="4306824"/>
             <a:ext cx="448056" cy="640080"/>
           </a:xfrm>
           <a:prstGeom prst="rect">
@@ -1886,7 +1886,7 @@
         </p:nvSpPr>
         <p:spPr>
           <a:xfrm>
-            <a:off x="2916936" y="1965960"/>
+            <a:off x="8961120" y="4306824"/>
             <a:ext cx="448056" cy="640080"/>
           </a:xfrm>
           <a:prstGeom prst="rect">
@@ -1911,7 +1911,7 @@
         </p:nvSpPr>
         <p:spPr>
           <a:xfrm>
-            <a:off x="2916936" y="1965960"/>
+            <a:off x="8961120" y="4306824"/>
             <a:ext cx="448056" cy="640080"/>
           </a:xfrm>
           <a:prstGeom prst="rect">
@@ -1967,7 +1967,7 @@
         </p:nvSpPr>
         <p:spPr>
           <a:xfrm>
-            <a:off x="3429000" y="1965960"/>
+            <a:off x="8449056" y="4306824"/>
             <a:ext cx="448056" cy="640080"/>
           </a:xfrm>
           <a:prstGeom prst="rect">
@@ -1992,7 +1992,7 @@
         </p:nvSpPr>
         <p:spPr>
           <a:xfrm>
-            <a:off x="3429000" y="1965960"/>
+            <a:off x="8449056" y="4306824"/>
             <a:ext cx="448056" cy="640080"/>
           </a:xfrm>
           <a:prstGeom prst="rect">
@@ -2048,7 +2048,7 @@
         </p:nvSpPr>
         <p:spPr>
           <a:xfrm>
-            <a:off x="3941064" y="1965960"/>
+            <a:off x="7936992" y="4306824"/>
             <a:ext cx="448056" cy="640080"/>
           </a:xfrm>
           <a:prstGeom prst="rect">
@@ -2073,7 +2073,7 @@
         </p:nvSpPr>
         <p:spPr>
           <a:xfrm>
-            <a:off x="3941064" y="1965960"/>
+            <a:off x="7936992" y="4306824"/>
             <a:ext cx="448056" cy="640080"/>
           </a:xfrm>
           <a:prstGeom prst="rect">
@@ -2129,7 +2129,7 @@
         </p:nvSpPr>
         <p:spPr>
           <a:xfrm>
-            <a:off x="4453128" y="1965960"/>
+            <a:off x="7424928" y="4306824"/>
             <a:ext cx="448056" cy="640080"/>
           </a:xfrm>
           <a:prstGeom prst="rect">
@@ -2154,7 +2154,7 @@
         </p:nvSpPr>
         <p:spPr>
           <a:xfrm>
-            <a:off x="4453128" y="1965960"/>
+            <a:off x="7424928" y="4306824"/>
             <a:ext cx="448056" cy="640080"/>
           </a:xfrm>
           <a:prstGeom prst="rect">
@@ -2210,7 +2210,7 @@
         </p:nvSpPr>
         <p:spPr>
           <a:xfrm>
-            <a:off x="4965192" y="1965960"/>
+            <a:off x="6912864" y="4306824"/>
             <a:ext cx="448056" cy="640080"/>
           </a:xfrm>
           <a:prstGeom prst="rect">
@@ -2235,7 +2235,7 @@
         </p:nvSpPr>
         <p:spPr>
           <a:xfrm>
-            <a:off x="4965192" y="1965960"/>
+            <a:off x="6912864" y="4306824"/>
             <a:ext cx="448056" cy="640080"/>
           </a:xfrm>
           <a:prstGeom prst="rect">
@@ -2291,7 +2291,7 @@
         </p:nvSpPr>
         <p:spPr>
           <a:xfrm>
-            <a:off x="9253728" y="1965960"/>
+            <a:off x="2624328" y="4306824"/>
             <a:ext cx="448056" cy="640080"/>
           </a:xfrm>
           <a:prstGeom prst="rect">
@@ -2316,7 +2316,7 @@
         </p:nvSpPr>
         <p:spPr>
           <a:xfrm>
-            <a:off x="9253728" y="1965960"/>
+            <a:off x="2624328" y="4306824"/>
             <a:ext cx="448056" cy="640080"/>
           </a:xfrm>
           <a:prstGeom prst="rect">
@@ -2372,7 +2372,7 @@
         </p:nvSpPr>
         <p:spPr>
           <a:xfrm>
-            <a:off x="9765792" y="1965960"/>
+            <a:off x="2112264" y="4306824"/>
             <a:ext cx="448056" cy="640080"/>
           </a:xfrm>
           <a:prstGeom prst="rect">
@@ -2397,7 +2397,7 @@
         </p:nvSpPr>
         <p:spPr>
           <a:xfrm>
-            <a:off x="9765792" y="1965960"/>
+            <a:off x="2112264" y="4306824"/>
             <a:ext cx="448056" cy="640080"/>
           </a:xfrm>
           <a:prstGeom prst="rect">
@@ -2453,7 +2453,7 @@
         </p:nvSpPr>
         <p:spPr>
           <a:xfrm>
-            <a:off x="10277856" y="1965960"/>
+            <a:off x="1600200" y="4306824"/>
             <a:ext cx="448056" cy="640080"/>
           </a:xfrm>
           <a:prstGeom prst="rect">
@@ -2478,7 +2478,7 @@
         </p:nvSpPr>
         <p:spPr>
           <a:xfrm>
-            <a:off x="10277856" y="1965960"/>
+            <a:off x="1600200" y="4306824"/>
             <a:ext cx="448056" cy="640080"/>
           </a:xfrm>
           <a:prstGeom prst="rect">
@@ -2534,7 +2534,7 @@
         </p:nvSpPr>
         <p:spPr>
           <a:xfrm>
-            <a:off x="868680" y="2862072"/>
+            <a:off x="11009376" y="3410712"/>
             <a:ext cx="448056" cy="640080"/>
           </a:xfrm>
           <a:prstGeom prst="rect">
@@ -2559,7 +2559,7 @@
         </p:nvSpPr>
         <p:spPr>
           <a:xfrm>
-            <a:off x="868680" y="2862072"/>
+            <a:off x="11009376" y="3410712"/>
             <a:ext cx="448056" cy="640080"/>
           </a:xfrm>
           <a:prstGeom prst="rect">
@@ -2615,7 +2615,7 @@
         </p:nvSpPr>
         <p:spPr>
           <a:xfrm>
-            <a:off x="1380744" y="2862072"/>
+            <a:off x="10497312" y="3410712"/>
             <a:ext cx="448056" cy="640080"/>
           </a:xfrm>
           <a:prstGeom prst="rect">
@@ -2640,7 +2640,7 @@
         </p:nvSpPr>
         <p:spPr>
           <a:xfrm>
-            <a:off x="1380744" y="2862072"/>
+            <a:off x="10497312" y="3410712"/>
             <a:ext cx="448056" cy="640080"/>
           </a:xfrm>
           <a:prstGeom prst="rect">
@@ -2696,7 +2696,7 @@
         </p:nvSpPr>
         <p:spPr>
           <a:xfrm>
-            <a:off x="1892808" y="2862072"/>
+            <a:off x="9985248" y="3410712"/>
             <a:ext cx="448056" cy="640080"/>
           </a:xfrm>
           <a:prstGeom prst="rect">
@@ -2721,7 +2721,7 @@
         </p:nvSpPr>
         <p:spPr>
           <a:xfrm>
-            <a:off x="1892808" y="2862072"/>
+            <a:off x="9985248" y="3410712"/>
             <a:ext cx="448056" cy="640080"/>
           </a:xfrm>
           <a:prstGeom prst="rect">
@@ -2777,7 +2777,7 @@
         </p:nvSpPr>
         <p:spPr>
           <a:xfrm>
-            <a:off x="2404872" y="2862072"/>
+            <a:off x="9473184" y="3410712"/>
             <a:ext cx="448056" cy="640080"/>
           </a:xfrm>
           <a:prstGeom prst="rect">
@@ -2802,7 +2802,7 @@
         </p:nvSpPr>
         <p:spPr>
           <a:xfrm>
-            <a:off x="2404872" y="2862072"/>
+            <a:off x="9473184" y="3410712"/>
             <a:ext cx="448056" cy="640080"/>
           </a:xfrm>
           <a:prstGeom prst="rect">
@@ -2858,7 +2858,7 @@
         </p:nvSpPr>
         <p:spPr>
           <a:xfrm>
-            <a:off x="2916936" y="2862072"/>
+            <a:off x="8961120" y="3410712"/>
             <a:ext cx="448056" cy="640080"/>
           </a:xfrm>
           <a:prstGeom prst="rect">
@@ -2883,7 +2883,7 @@
         </p:nvSpPr>
         <p:spPr>
           <a:xfrm>
-            <a:off x="2916936" y="2862072"/>
+            <a:off x="8961120" y="3410712"/>
             <a:ext cx="448056" cy="640080"/>
           </a:xfrm>
           <a:prstGeom prst="rect">
@@ -2939,7 +2939,7 @@
         </p:nvSpPr>
         <p:spPr>
           <a:xfrm>
-            <a:off x="3429000" y="2862072"/>
+            <a:off x="8449056" y="3410712"/>
             <a:ext cx="448056" cy="640080"/>
           </a:xfrm>
           <a:prstGeom prst="rect">
@@ -2964,7 +2964,7 @@
         </p:nvSpPr>
         <p:spPr>
           <a:xfrm>
-            <a:off x="3429000" y="2862072"/>
+            <a:off x="8449056" y="3410712"/>
             <a:ext cx="448056" cy="640080"/>
           </a:xfrm>
           <a:prstGeom prst="rect">
@@ -3020,7 +3020,7 @@
         </p:nvSpPr>
         <p:spPr>
           <a:xfrm>
-            <a:off x="3941064" y="2862072"/>
+            <a:off x="7936992" y="3410712"/>
             <a:ext cx="448056" cy="640080"/>
           </a:xfrm>
           <a:prstGeom prst="rect">
@@ -3045,7 +3045,7 @@
         </p:nvSpPr>
         <p:spPr>
           <a:xfrm>
-            <a:off x="3941064" y="2862072"/>
+            <a:off x="7936992" y="3410712"/>
             <a:ext cx="448056" cy="640080"/>
           </a:xfrm>
           <a:prstGeom prst="rect">
@@ -3101,7 +3101,7 @@
         </p:nvSpPr>
         <p:spPr>
           <a:xfrm>
-            <a:off x="4453128" y="2862072"/>
+            <a:off x="7424928" y="3410712"/>
             <a:ext cx="448056" cy="640080"/>
           </a:xfrm>
           <a:prstGeom prst="rect">
@@ -3126,7 +3126,7 @@
         </p:nvSpPr>
         <p:spPr>
           <a:xfrm>
-            <a:off x="4453128" y="2862072"/>
+            <a:off x="7424928" y="3410712"/>
             <a:ext cx="448056" cy="640080"/>
           </a:xfrm>
           <a:prstGeom prst="rect">
@@ -3182,7 +3182,7 @@
         </p:nvSpPr>
         <p:spPr>
           <a:xfrm>
-            <a:off x="4965192" y="2862072"/>
+            <a:off x="6912864" y="3410712"/>
             <a:ext cx="448056" cy="640080"/>
           </a:xfrm>
           <a:prstGeom prst="rect">
@@ -3207,7 +3207,7 @@
         </p:nvSpPr>
         <p:spPr>
           <a:xfrm>
-            <a:off x="4965192" y="2862072"/>
+            <a:off x="6912864" y="3410712"/>
             <a:ext cx="448056" cy="640080"/>
           </a:xfrm>
           <a:prstGeom prst="rect">
@@ -3263,7 +3263,7 @@
         </p:nvSpPr>
         <p:spPr>
           <a:xfrm>
-            <a:off x="9253728" y="2862072"/>
+            <a:off x="2624328" y="3410712"/>
             <a:ext cx="448056" cy="640080"/>
           </a:xfrm>
           <a:prstGeom prst="rect">
@@ -3288,7 +3288,7 @@
         </p:nvSpPr>
         <p:spPr>
           <a:xfrm>
-            <a:off x="9253728" y="2862072"/>
+            <a:off x="2624328" y="3410712"/>
             <a:ext cx="448056" cy="640080"/>
           </a:xfrm>
           <a:prstGeom prst="rect">
@@ -3344,7 +3344,7 @@
         </p:nvSpPr>
         <p:spPr>
           <a:xfrm>
-            <a:off x="9765792" y="2862072"/>
+            <a:off x="2112264" y="3410712"/>
             <a:ext cx="448056" cy="640080"/>
           </a:xfrm>
           <a:prstGeom prst="rect">
@@ -3369,7 +3369,7 @@
         </p:nvSpPr>
         <p:spPr>
           <a:xfrm>
-            <a:off x="9765792" y="2862072"/>
+            <a:off x="2112264" y="3410712"/>
             <a:ext cx="448056" cy="640080"/>
           </a:xfrm>
           <a:prstGeom prst="rect">
@@ -3425,7 +3425,7 @@
         </p:nvSpPr>
         <p:spPr>
           <a:xfrm>
-            <a:off x="10277856" y="2862072"/>
+            <a:off x="1600200" y="3410712"/>
             <a:ext cx="448056" cy="640080"/>
           </a:xfrm>
           <a:prstGeom prst="rect">
@@ -3450,7 +3450,7 @@
         </p:nvSpPr>
         <p:spPr>
           <a:xfrm>
-            <a:off x="10277856" y="2862072"/>
+            <a:off x="1600200" y="3410712"/>
             <a:ext cx="448056" cy="640080"/>
           </a:xfrm>
           <a:prstGeom prst="rect">
@@ -3506,7 +3506,7 @@
         </p:nvSpPr>
         <p:spPr>
           <a:xfrm>
-            <a:off x="868680" y="3502152"/>
+            <a:off x="11009376" y="2770632"/>
             <a:ext cx="448056" cy="640080"/>
           </a:xfrm>
           <a:prstGeom prst="rect">
@@ -3531,7 +3531,7 @@
         </p:nvSpPr>
         <p:spPr>
           <a:xfrm>
-            <a:off x="868680" y="3502152"/>
+            <a:off x="11009376" y="2770632"/>
             <a:ext cx="448056" cy="640080"/>
           </a:xfrm>
           <a:prstGeom prst="rect">
@@ -3587,7 +3587,7 @@
         </p:nvSpPr>
         <p:spPr>
           <a:xfrm>
-            <a:off x="1380744" y="3502152"/>
+            <a:off x="10497312" y="2770632"/>
             <a:ext cx="448056" cy="640080"/>
           </a:xfrm>
           <a:prstGeom prst="rect">
@@ -3612,7 +3612,7 @@
         </p:nvSpPr>
         <p:spPr>
           <a:xfrm>
-            <a:off x="1380744" y="3502152"/>
+            <a:off x="10497312" y="2770632"/>
             <a:ext cx="448056" cy="640080"/>
           </a:xfrm>
           <a:prstGeom prst="rect">
@@ -3668,7 +3668,7 @@
         </p:nvSpPr>
         <p:spPr>
           <a:xfrm>
-            <a:off x="1892808" y="3502152"/>
+            <a:off x="9985248" y="2770632"/>
             <a:ext cx="448056" cy="640080"/>
           </a:xfrm>
           <a:prstGeom prst="rect">
@@ -3693,7 +3693,7 @@
         </p:nvSpPr>
         <p:spPr>
           <a:xfrm>
-            <a:off x="1892808" y="3502152"/>
+            <a:off x="9985248" y="2770632"/>
             <a:ext cx="448056" cy="640080"/>
           </a:xfrm>
           <a:prstGeom prst="rect">
@@ -3749,7 +3749,7 @@
         </p:nvSpPr>
         <p:spPr>
           <a:xfrm>
-            <a:off x="2404872" y="3502152"/>
+            <a:off x="9473184" y="2770632"/>
             <a:ext cx="448056" cy="640080"/>
           </a:xfrm>
           <a:prstGeom prst="rect">
@@ -3774,7 +3774,7 @@
         </p:nvSpPr>
         <p:spPr>
           <a:xfrm>
-            <a:off x="2404872" y="3502152"/>
+            <a:off x="9473184" y="2770632"/>
             <a:ext cx="448056" cy="640080"/>
           </a:xfrm>
           <a:prstGeom prst="rect">
@@ -3830,7 +3830,7 @@
         </p:nvSpPr>
         <p:spPr>
           <a:xfrm>
-            <a:off x="2916936" y="3502152"/>
+            <a:off x="8961120" y="2770632"/>
             <a:ext cx="448056" cy="640080"/>
           </a:xfrm>
           <a:prstGeom prst="rect">
@@ -3855,7 +3855,7 @@
         </p:nvSpPr>
         <p:spPr>
           <a:xfrm>
-            <a:off x="2916936" y="3502152"/>
+            <a:off x="8961120" y="2770632"/>
             <a:ext cx="448056" cy="640080"/>
           </a:xfrm>
           <a:prstGeom prst="rect">
@@ -3911,7 +3911,7 @@
         </p:nvSpPr>
         <p:spPr>
           <a:xfrm>
-            <a:off x="3429000" y="3502152"/>
+            <a:off x="8449056" y="2770632"/>
             <a:ext cx="448056" cy="640080"/>
           </a:xfrm>
           <a:prstGeom prst="rect">
@@ -3936,7 +3936,7 @@
         </p:nvSpPr>
         <p:spPr>
           <a:xfrm>
-            <a:off x="3429000" y="3502152"/>
+            <a:off x="8449056" y="2770632"/>
             <a:ext cx="448056" cy="640080"/>
           </a:xfrm>
           <a:prstGeom prst="rect">
@@ -3992,7 +3992,7 @@
         </p:nvSpPr>
         <p:spPr>
           <a:xfrm>
-            <a:off x="3941064" y="3502152"/>
+            <a:off x="7936992" y="2770632"/>
             <a:ext cx="448056" cy="640080"/>
           </a:xfrm>
           <a:prstGeom prst="rect">
@@ -4017,7 +4017,7 @@
         </p:nvSpPr>
         <p:spPr>
           <a:xfrm>
-            <a:off x="3941064" y="3502152"/>
+            <a:off x="7936992" y="2770632"/>
             <a:ext cx="448056" cy="640080"/>
           </a:xfrm>
           <a:prstGeom prst="rect">
@@ -4073,7 +4073,7 @@
         </p:nvSpPr>
         <p:spPr>
           <a:xfrm>
-            <a:off x="4453128" y="3502152"/>
+            <a:off x="7424928" y="2770632"/>
             <a:ext cx="448056" cy="640080"/>
           </a:xfrm>
           <a:prstGeom prst="rect">
@@ -4098,7 +4098,7 @@
         </p:nvSpPr>
         <p:spPr>
           <a:xfrm>
-            <a:off x="4453128" y="3502152"/>
+            <a:off x="7424928" y="2770632"/>
             <a:ext cx="448056" cy="640080"/>
           </a:xfrm>
           <a:prstGeom prst="rect">
@@ -4154,7 +4154,7 @@
         </p:nvSpPr>
         <p:spPr>
           <a:xfrm>
-            <a:off x="4965192" y="3502152"/>
+            <a:off x="6912864" y="2770632"/>
             <a:ext cx="448056" cy="640080"/>
           </a:xfrm>
           <a:prstGeom prst="rect">
@@ -4179,7 +4179,7 @@
         </p:nvSpPr>
         <p:spPr>
           <a:xfrm>
-            <a:off x="4965192" y="3502152"/>
+            <a:off x="6912864" y="2770632"/>
             <a:ext cx="448056" cy="640080"/>
           </a:xfrm>
           <a:prstGeom prst="rect">
@@ -4235,7 +4235,7 @@
         </p:nvSpPr>
         <p:spPr>
           <a:xfrm>
-            <a:off x="9253728" y="3502152"/>
+            <a:off x="2624328" y="2770632"/>
             <a:ext cx="448056" cy="640080"/>
           </a:xfrm>
           <a:prstGeom prst="rect">
@@ -4260,7 +4260,7 @@
         </p:nvSpPr>
         <p:spPr>
           <a:xfrm>
-            <a:off x="9253728" y="3502152"/>
+            <a:off x="2624328" y="2770632"/>
             <a:ext cx="448056" cy="640080"/>
           </a:xfrm>
           <a:prstGeom prst="rect">
@@ -4316,7 +4316,7 @@
         </p:nvSpPr>
         <p:spPr>
           <a:xfrm>
-            <a:off x="9765792" y="3502152"/>
+            <a:off x="2112264" y="2770632"/>
             <a:ext cx="448056" cy="640080"/>
           </a:xfrm>
           <a:prstGeom prst="rect">
@@ -4341,7 +4341,7 @@
         </p:nvSpPr>
         <p:spPr>
           <a:xfrm>
-            <a:off x="9765792" y="3502152"/>
+            <a:off x="2112264" y="2770632"/>
             <a:ext cx="448056" cy="640080"/>
           </a:xfrm>
           <a:prstGeom prst="rect">
@@ -4397,7 +4397,7 @@
         </p:nvSpPr>
         <p:spPr>
           <a:xfrm>
-            <a:off x="10277856" y="3502152"/>
+            <a:off x="1600200" y="2770632"/>
             <a:ext cx="448056" cy="640080"/>
           </a:xfrm>
           <a:prstGeom prst="rect">
@@ -4422,7 +4422,7 @@
         </p:nvSpPr>
         <p:spPr>
           <a:xfrm>
-            <a:off x="10277856" y="3502152"/>
+            <a:off x="1600200" y="2770632"/>
             <a:ext cx="448056" cy="640080"/>
           </a:xfrm>
           <a:prstGeom prst="rect">
@@ -4478,7 +4478,7 @@
         </p:nvSpPr>
         <p:spPr>
           <a:xfrm>
-            <a:off x="868680" y="4398264"/>
+            <a:off x="11009376" y="1874520"/>
             <a:ext cx="448056" cy="640080"/>
           </a:xfrm>
           <a:prstGeom prst="rect">
@@ -4503,7 +4503,7 @@
         </p:nvSpPr>
         <p:spPr>
           <a:xfrm>
-            <a:off x="868680" y="4398264"/>
+            <a:off x="11009376" y="1874520"/>
             <a:ext cx="448056" cy="640080"/>
           </a:xfrm>
           <a:prstGeom prst="rect">
@@ -4559,7 +4559,7 @@
         </p:nvSpPr>
         <p:spPr>
           <a:xfrm>
-            <a:off x="1380744" y="4398264"/>
+            <a:off x="10497312" y="1874520"/>
             <a:ext cx="448056" cy="640080"/>
           </a:xfrm>
           <a:prstGeom prst="rect">
@@ -4584,7 +4584,7 @@
         </p:nvSpPr>
         <p:spPr>
           <a:xfrm>
-            <a:off x="1380744" y="4398264"/>
+            <a:off x="10497312" y="1874520"/>
             <a:ext cx="448056" cy="640080"/>
           </a:xfrm>
           <a:prstGeom prst="rect">
@@ -4640,7 +4640,7 @@
         </p:nvSpPr>
         <p:spPr>
           <a:xfrm>
-            <a:off x="1892808" y="4398264"/>
+            <a:off x="9985248" y="1874520"/>
             <a:ext cx="448056" cy="640080"/>
           </a:xfrm>
           <a:prstGeom prst="rect">
@@ -4665,7 +4665,7 @@
         </p:nvSpPr>
         <p:spPr>
           <a:xfrm>
-            <a:off x="1892808" y="4398264"/>
+            <a:off x="9985248" y="1874520"/>
             <a:ext cx="448056" cy="640080"/>
           </a:xfrm>
           <a:prstGeom prst="rect">
@@ -4721,7 +4721,7 @@
         </p:nvSpPr>
         <p:spPr>
           <a:xfrm>
-            <a:off x="2404872" y="4398264"/>
+            <a:off x="9473184" y="1874520"/>
             <a:ext cx="448056" cy="640080"/>
           </a:xfrm>
           <a:prstGeom prst="rect">
@@ -4746,7 +4746,7 @@
         </p:nvSpPr>
         <p:spPr>
           <a:xfrm>
-            <a:off x="2404872" y="4398264"/>
+            <a:off x="9473184" y="1874520"/>
             <a:ext cx="448056" cy="640080"/>
           </a:xfrm>
           <a:prstGeom prst="rect">
@@ -4802,7 +4802,7 @@
         </p:nvSpPr>
         <p:spPr>
           <a:xfrm>
-            <a:off x="2916936" y="4398264"/>
+            <a:off x="8961120" y="1874520"/>
             <a:ext cx="448056" cy="640080"/>
           </a:xfrm>
           <a:prstGeom prst="rect">
@@ -4827,7 +4827,7 @@
         </p:nvSpPr>
         <p:spPr>
           <a:xfrm>
-            <a:off x="2916936" y="4398264"/>
+            <a:off x="8961120" y="1874520"/>
             <a:ext cx="448056" cy="640080"/>
           </a:xfrm>
           <a:prstGeom prst="rect">
@@ -4883,7 +4883,7 @@
         </p:nvSpPr>
         <p:spPr>
           <a:xfrm>
-            <a:off x="3429000" y="4398264"/>
+            <a:off x="8449056" y="1874520"/>
             <a:ext cx="448056" cy="640080"/>
           </a:xfrm>
           <a:prstGeom prst="rect">
@@ -4908,7 +4908,7 @@
         </p:nvSpPr>
         <p:spPr>
           <a:xfrm>
-            <a:off x="3429000" y="4398264"/>
+            <a:off x="8449056" y="1874520"/>
             <a:ext cx="448056" cy="640080"/>
           </a:xfrm>
           <a:prstGeom prst="rect">
@@ -4964,7 +4964,7 @@
         </p:nvSpPr>
         <p:spPr>
           <a:xfrm>
-            <a:off x="3941064" y="4398264"/>
+            <a:off x="7936992" y="1874520"/>
             <a:ext cx="448056" cy="640080"/>
           </a:xfrm>
           <a:prstGeom prst="rect">
@@ -4989,7 +4989,7 @@
         </p:nvSpPr>
         <p:spPr>
           <a:xfrm>
-            <a:off x="3941064" y="4398264"/>
+            <a:off x="7936992" y="1874520"/>
             <a:ext cx="448056" cy="640080"/>
           </a:xfrm>
           <a:prstGeom prst="rect">
@@ -5045,7 +5045,7 @@
         </p:nvSpPr>
         <p:spPr>
           <a:xfrm>
-            <a:off x="4453128" y="4398264"/>
+            <a:off x="7424928" y="1874520"/>
             <a:ext cx="448056" cy="640080"/>
           </a:xfrm>
           <a:prstGeom prst="rect">
@@ -5070,7 +5070,7 @@
         </p:nvSpPr>
         <p:spPr>
           <a:xfrm>
-            <a:off x="4453128" y="4398264"/>
+            <a:off x="7424928" y="1874520"/>
             <a:ext cx="448056" cy="640080"/>
           </a:xfrm>
           <a:prstGeom prst="rect">
@@ -5126,7 +5126,7 @@
         </p:nvSpPr>
         <p:spPr>
           <a:xfrm>
-            <a:off x="4965192" y="4398264"/>
+            <a:off x="6912864" y="1874520"/>
             <a:ext cx="448056" cy="640080"/>
           </a:xfrm>
           <a:prstGeom prst="rect">
@@ -5151,7 +5151,7 @@
         </p:nvSpPr>
         <p:spPr>
           <a:xfrm>
-            <a:off x="4965192" y="4398264"/>
+            <a:off x="6912864" y="1874520"/>
             <a:ext cx="448056" cy="640080"/>
           </a:xfrm>
           <a:prstGeom prst="rect">
@@ -5207,7 +5207,7 @@
         </p:nvSpPr>
         <p:spPr>
           <a:xfrm>
-            <a:off x="9253728" y="4398264"/>
+            <a:off x="2624328" y="1874520"/>
             <a:ext cx="448056" cy="640080"/>
           </a:xfrm>
           <a:prstGeom prst="rect">
@@ -5232,7 +5232,7 @@
         </p:nvSpPr>
         <p:spPr>
           <a:xfrm>
-            <a:off x="9253728" y="4398264"/>
+            <a:off x="2624328" y="1874520"/>
             <a:ext cx="448056" cy="640080"/>
           </a:xfrm>
           <a:prstGeom prst="rect">
@@ -5288,7 +5288,7 @@
         </p:nvSpPr>
         <p:spPr>
           <a:xfrm>
-            <a:off x="9765792" y="4398264"/>
+            <a:off x="2112264" y="1874520"/>
             <a:ext cx="448056" cy="640080"/>
           </a:xfrm>
           <a:prstGeom prst="rect">
@@ -5313,7 +5313,7 @@
         </p:nvSpPr>
         <p:spPr>
           <a:xfrm>
-            <a:off x="9765792" y="4398264"/>
+            <a:off x="2112264" y="1874520"/>
             <a:ext cx="448056" cy="640080"/>
           </a:xfrm>
           <a:prstGeom prst="rect">
@@ -5369,7 +5369,7 @@
         </p:nvSpPr>
         <p:spPr>
           <a:xfrm>
-            <a:off x="10277856" y="4398264"/>
+            <a:off x="1600200" y="1874520"/>
             <a:ext cx="448056" cy="640080"/>
           </a:xfrm>
           <a:prstGeom prst="rect">
@@ -5394,7 +5394,7 @@
         </p:nvSpPr>
         <p:spPr>
           <a:xfrm>
-            <a:off x="10277856" y="4398264"/>
+            <a:off x="1600200" y="1874520"/>
             <a:ext cx="448056" cy="640080"/>
           </a:xfrm>
           <a:prstGeom prst="rect">
@@ -5450,7 +5450,7 @@
         </p:nvSpPr>
         <p:spPr>
           <a:xfrm>
-            <a:off x="868680" y="5148072"/>
+            <a:off x="9985248" y="5056632"/>
             <a:ext cx="1472184" cy="292608"/>
           </a:xfrm>
           <a:prstGeom prst="roundRect">
@@ -5477,7 +5477,7 @@
         </p:nvSpPr>
         <p:spPr>
           <a:xfrm>
-            <a:off x="868680" y="5148072"/>
+            <a:off x="9985248" y="5056632"/>
             <a:ext cx="1472184" cy="292608"/>
           </a:xfrm>
           <a:prstGeom prst="rect">
@@ -5516,7 +5516,7 @@
         </p:nvSpPr>
         <p:spPr>
           <a:xfrm>
-            <a:off x="2404872" y="5148072"/>
+            <a:off x="8449056" y="5056632"/>
             <a:ext cx="1472184" cy="292608"/>
           </a:xfrm>
           <a:prstGeom prst="roundRect">
@@ -5543,7 +5543,7 @@
         </p:nvSpPr>
         <p:spPr>
           <a:xfrm>
-            <a:off x="2404872" y="5148072"/>
+            <a:off x="8449056" y="5056632"/>
             <a:ext cx="1472184" cy="292608"/>
           </a:xfrm>
           <a:prstGeom prst="rect">
@@ -5582,7 +5582,7 @@
         </p:nvSpPr>
         <p:spPr>
           <a:xfrm>
-            <a:off x="3941064" y="5148072"/>
+            <a:off x="6912864" y="5056632"/>
             <a:ext cx="1472184" cy="292608"/>
           </a:xfrm>
           <a:prstGeom prst="roundRect">
@@ -5609,7 +5609,7 @@
         </p:nvSpPr>
         <p:spPr>
           <a:xfrm>
-            <a:off x="3941064" y="5148072"/>
+            <a:off x="6912864" y="5056632"/>
             <a:ext cx="1472184" cy="292608"/>
           </a:xfrm>
           <a:prstGeom prst="rect">
@@ -5648,7 +5648,7 @@
         </p:nvSpPr>
         <p:spPr>
           <a:xfrm>
-            <a:off x="9253728" y="5148072"/>
+            <a:off x="1600200" y="5056632"/>
             <a:ext cx="1472184" cy="292608"/>
           </a:xfrm>
           <a:prstGeom prst="roundRect">
@@ -5675,7 +5675,7 @@
         </p:nvSpPr>
         <p:spPr>
           <a:xfrm>
-            <a:off x="9253728" y="5148072"/>
+            <a:off x="1600200" y="5056632"/>
             <a:ext cx="1472184" cy="292608"/>
           </a:xfrm>
           <a:prstGeom prst="rect">
@@ -5714,7 +5714,7 @@
         </p:nvSpPr>
         <p:spPr>
           <a:xfrm>
-            <a:off x="868680" y="5495544"/>
+            <a:off x="6912864" y="5404104"/>
             <a:ext cx="4544568" cy="274320"/>
           </a:xfrm>
           <a:prstGeom prst="rect">
@@ -5753,7 +5753,7 @@
         </p:nvSpPr>
         <p:spPr>
           <a:xfrm>
-            <a:off x="8979408" y="5495544"/>
+            <a:off x="1325880" y="5404104"/>
             <a:ext cx="2020824" cy="274320"/>
           </a:xfrm>
           <a:prstGeom prst="rect">
@@ -5786,13 +5786,77 @@
       </p:sp>
       <p:sp>
         <p:nvSpPr>
-          <p:cNvPr id="118" name="Shape 116"/>
+          <p:cNvPr id="118" name="facing field arrow"/>
           <p:cNvSpPr/>
           <p:nvPr/>
         </p:nvSpPr>
         <p:spPr>
           <a:xfrm>
-            <a:off x="868680" y="1673352"/>
+            <a:off x="4215384" y="5129784"/>
+            <a:ext cx="274320" cy="365760"/>
+          </a:xfrm>
+          <a:prstGeom prst="upArrow">
+            <a:avLst/>
+          </a:prstGeom>
+          <a:solidFill>
+            <a:schemeClr val="accent5"/>
+          </a:solidFill>
+          <a:ln w="12700">
+            <a:solidFill>
+              <a:schemeClr val="accent5"/>
+            </a:solidFill>
+            <a:prstDash val="solid"/>
+          </a:ln>
+        </p:spPr>
+      </p:sp>
+      <p:sp>
+        <p:nvSpPr>
+          <p:cNvPr id="119" name="Text 117"/>
+          <p:cNvSpPr txBox="1"/>
+          <p:nvPr/>
+        </p:nvSpPr>
+        <p:spPr>
+          <a:xfrm>
+            <a:off x="4581144" y="5129784"/>
+            <a:ext cx="1280160" cy="365760"/>
+          </a:xfrm>
+          <a:prstGeom prst="rect">
+            <a:avLst/>
+          </a:prstGeom>
+          <a:noFill/>
+          <a:ln/>
+        </p:spPr>
+        <p:txBody>
+          <a:bodyPr wrap="square" lIns="0" tIns="0" rIns="0" bIns="0" rtlCol="0" anchor="ctr"/>
+          <a:lstStyle/>
+          <a:p>
+            <a:pPr indent="0" marL="0">
+              <a:buNone/>
+            </a:pPr>
+            <a:r>
+              <a:rPr lang="en-US" sz="1200" i="1" dirty="0">
+                <a:solidFill>
+                  <a:srgbClr val="4A5A50"/>
+                </a:solidFill>
+                <a:latin typeface="Calibri" pitchFamily="34" charset="0"/>
+                <a:ea typeface="Calibri" pitchFamily="34" charset="-122"/>
+                <a:cs typeface="Calibri" pitchFamily="34" charset="-120"/>
+              </a:rPr>
+              <a:t>Facing field</a:t>
+            </a:r>
+            <a:endParaRPr lang="en-US" sz="1200" dirty="0"/>
+          </a:p>
+        </p:txBody>
+      </p:sp>
+      <p:sp>
+        <p:nvSpPr>
+          <p:cNvPr id="120" name="Shape 118"/>
+          <p:cNvSpPr/>
+          <p:nvPr/>
+        </p:nvSpPr>
+        <p:spPr>
+          <a:xfrm>
+            <a:off x="6912864" y="1581912"/>
             <a:ext cx="4544568" cy="0"/>
           </a:xfrm>
           <a:prstGeom prst="line">
@@ -5811,13 +5875,13 @@
       </p:sp>
       <p:sp>
         <p:nvSpPr>
-          <p:cNvPr id="119" name="Text 117"/>
+          <p:cNvPr id="121" name="Text 119"/>
           <p:cNvSpPr txBox="1"/>
           <p:nvPr/>
         </p:nvSpPr>
         <p:spPr>
           <a:xfrm>
-            <a:off x="868680" y="1399032"/>
+            <a:off x="6912864" y="1307592"/>
             <a:ext cx="4544568" cy="237744"/>
           </a:xfrm>
           <a:prstGeom prst="rect">
@@ -5850,13 +5914,13 @@
       </p:sp>
       <p:sp>
         <p:nvSpPr>
-          <p:cNvPr id="120" name="Shape 118"/>
+          <p:cNvPr id="122" name="Shape 120"/>
           <p:cNvSpPr/>
           <p:nvPr/>
         </p:nvSpPr>
         <p:spPr>
           <a:xfrm>
-            <a:off x="5413248" y="1673352"/>
+            <a:off x="3072384" y="1581912"/>
             <a:ext cx="3840480" cy="0"/>
           </a:xfrm>
           <a:prstGeom prst="line">
@@ -5875,13 +5939,13 @@
       </p:sp>
       <p:sp>
         <p:nvSpPr>
-          <p:cNvPr id="121" name="Text 119"/>
+          <p:cNvPr id="123" name="Text 121"/>
           <p:cNvSpPr txBox="1"/>
           <p:nvPr/>
         </p:nvSpPr>
         <p:spPr>
           <a:xfrm>
-            <a:off x="5413248" y="1399032"/>
+            <a:off x="3072384" y="1307592"/>
             <a:ext cx="3840480" cy="237744"/>
           </a:xfrm>
           <a:prstGeom prst="rect">
@@ -5914,13 +5978,13 @@
       </p:sp>
       <p:sp>
         <p:nvSpPr>
-          <p:cNvPr id="122" name="Shape 120"/>
+          <p:cNvPr id="124" name="Shape 122"/>
           <p:cNvSpPr/>
           <p:nvPr/>
         </p:nvSpPr>
         <p:spPr>
           <a:xfrm>
-            <a:off x="9253728" y="1673352"/>
+            <a:off x="1600200" y="1581912"/>
             <a:ext cx="1472184" cy="0"/>
           </a:xfrm>
           <a:prstGeom prst="line">
@@ -5939,13 +6003,13 @@
       </p:sp>
       <p:sp>
         <p:nvSpPr>
-          <p:cNvPr id="123" name="Text 121"/>
+          <p:cNvPr id="125" name="Text 123"/>
           <p:cNvSpPr txBox="1"/>
           <p:nvPr/>
         </p:nvSpPr>
         <p:spPr>
           <a:xfrm>
-            <a:off x="9253728" y="1399032"/>
+            <a:off x="1600200" y="1307592"/>
             <a:ext cx="1472184" cy="237744"/>
           </a:xfrm>
           <a:prstGeom prst="rect">
@@ -5978,13 +6042,13 @@
       </p:sp>
       <p:sp>
         <p:nvSpPr>
-          <p:cNvPr id="124" name="Text 122"/>
+          <p:cNvPr id="126" name="Text 124"/>
           <p:cNvSpPr txBox="1"/>
           <p:nvPr/>
         </p:nvSpPr>
         <p:spPr>
           <a:xfrm>
-            <a:off x="868680" y="1106424"/>
+            <a:off x="1600200" y="1014984"/>
             <a:ext cx="9857232" cy="256032"/>
           </a:xfrm>
           <a:prstGeom prst="rect">
@@ -6017,17 +6081,83 @@
       </p:sp>
       <p:sp>
         <p:nvSpPr>
-          <p:cNvPr id="125" name="facing field arrow"/>
+          <p:cNvPr id="127" name="Shape 125"/>
           <p:cNvSpPr/>
           <p:nvPr/>
         </p:nvSpPr>
         <p:spPr>
           <a:xfrm>
-            <a:off x="868680" y="1106424"/>
-            <a:ext cx="274320" cy="256032"/>
-          </a:xfrm>
-          <a:prstGeom prst="downArrow">
-            <a:avLst/>
+            <a:off x="1417320" y="1874520"/>
+            <a:ext cx="0" cy="3072384"/>
+          </a:xfrm>
+          <a:prstGeom prst="line">
+            <a:avLst/>
+          </a:prstGeom>
+          <a:noFill/>
+          <a:ln w="12700">
+            <a:solidFill>
+              <a:srgbClr val="4A5A50"/>
+            </a:solidFill>
+            <a:prstDash val="solid"/>
+            <a:headEnd type="triangle"/>
+            <a:tailEnd type="triangle"/>
+          </a:ln>
+        </p:spPr>
+      </p:sp>
+      <p:sp>
+        <p:nvSpPr>
+          <p:cNvPr id="128" name="Text 126"/>
+          <p:cNvSpPr txBox="1"/>
+          <p:nvPr/>
+        </p:nvSpPr>
+        <p:spPr>
+          <a:xfrm>
+            <a:off x="868680" y="2103120"/>
+            <a:ext cx="475488" cy="274320"/>
+          </a:xfrm>
+          <a:prstGeom prst="rect">
+            <a:avLst/>
+          </a:prstGeom>
+          <a:noFill/>
+          <a:ln/>
+        </p:spPr>
+        <p:txBody>
+          <a:bodyPr wrap="square" lIns="0" tIns="0" rIns="0" bIns="0" rtlCol="0" anchor="ctr"/>
+          <a:lstStyle/>
+          <a:p>
+            <a:pPr algn="r" indent="0" marL="0">
+              <a:buNone/>
+            </a:pPr>
+            <a:r>
+              <a:rPr lang="en-US" sz="1200" b="1" dirty="0">
+                <a:solidFill>
+                  <a:schemeClr val="tx2"/>
+                </a:solidFill>
+                <a:latin typeface="Calibri" pitchFamily="34" charset="0"/>
+                <a:ea typeface="Calibri" pitchFamily="34" charset="-122"/>
+                <a:cs typeface="Calibri" pitchFamily="34" charset="-120"/>
+              </a:rPr>
+              <a:t>24 m</a:t>
+            </a:r>
+            <a:endParaRPr lang="en-US" sz="1200" dirty="0"/>
+          </a:p>
+        </p:txBody>
+      </p:sp>
+      <p:sp>
+        <p:nvSpPr>
+          <p:cNvPr id="129" name="Amrit Sarovar"/>
+          <p:cNvSpPr/>
+          <p:nvPr/>
+        </p:nvSpPr>
+        <p:spPr>
+          <a:xfrm>
+            <a:off x="320040" y="2907792"/>
+            <a:ext cx="868680" cy="1005840"/>
+          </a:xfrm>
+          <a:prstGeom prst="roundRect">
+            <a:avLst>
+              <a:gd name="adj" fmla="val 12632"/>
+            </a:avLst>
           </a:prstGeom>
           <a:solidFill>
             <a:schemeClr val="accent5"/>
@@ -6042,14 +6172,14 @@
       </p:sp>
       <p:sp>
         <p:nvSpPr>
-          <p:cNvPr id="126" name="Text 124"/>
+          <p:cNvPr id="130" name="Text 128"/>
           <p:cNvSpPr txBox="1"/>
           <p:nvPr/>
         </p:nvSpPr>
         <p:spPr>
           <a:xfrm>
-            <a:off x="1216152" y="1106424"/>
-            <a:ext cx="1280160" cy="256032"/>
+            <a:off x="320040" y="2907792"/>
+            <a:ext cx="868680" cy="1005840"/>
           </a:xfrm>
           <a:prstGeom prst="rect">
             <a:avLst/>
@@ -6061,83 +6191,19 @@
           <a:bodyPr wrap="square" lIns="0" tIns="0" rIns="0" bIns="0" rtlCol="0" anchor="ctr"/>
           <a:lstStyle/>
           <a:p>
-            <a:pPr indent="0" marL="0">
-              <a:buNone/>
-            </a:pPr>
-            <a:r>
-              <a:rPr lang="en-US" sz="1100" i="1" dirty="0">
-                <a:solidFill>
-                  <a:srgbClr val="4A5A50"/>
-                </a:solidFill>
-                <a:latin typeface="Calibri" pitchFamily="34" charset="0"/>
-                <a:ea typeface="Calibri" pitchFamily="34" charset="-122"/>
-                <a:cs typeface="Calibri" pitchFamily="34" charset="-120"/>
-              </a:rPr>
-              <a:t>Facing field</a:t>
-            </a:r>
-            <a:endParaRPr lang="en-US" sz="1100" dirty="0"/>
-          </a:p>
-        </p:txBody>
-      </p:sp>
-      <p:sp>
-        <p:nvSpPr>
-          <p:cNvPr id="127" name="Shape 125"/>
-          <p:cNvSpPr/>
-          <p:nvPr/>
-        </p:nvSpPr>
-        <p:spPr>
-          <a:xfrm>
-            <a:off x="594360" y="1965960"/>
-            <a:ext cx="0" cy="3072384"/>
-          </a:xfrm>
-          <a:prstGeom prst="line">
-            <a:avLst/>
-          </a:prstGeom>
-          <a:noFill/>
-          <a:ln w="12700">
-            <a:solidFill>
-              <a:srgbClr val="4A5A50"/>
-            </a:solidFill>
-            <a:prstDash val="solid"/>
-            <a:headEnd type="triangle"/>
-            <a:tailEnd type="triangle"/>
-          </a:ln>
-        </p:spPr>
-      </p:sp>
-      <p:sp>
-        <p:nvSpPr>
-          <p:cNvPr id="128" name="Text 126"/>
-          <p:cNvSpPr txBox="1"/>
-          <p:nvPr/>
-        </p:nvSpPr>
-        <p:spPr>
-          <a:xfrm>
-            <a:off x="91440" y="3364992"/>
-            <a:ext cx="457200" cy="274320"/>
-          </a:xfrm>
-          <a:prstGeom prst="rect">
-            <a:avLst/>
-          </a:prstGeom>
-          <a:noFill/>
-          <a:ln/>
-        </p:spPr>
-        <p:txBody>
-          <a:bodyPr wrap="square" lIns="0" tIns="0" rIns="0" bIns="0" rtlCol="0" anchor="ctr"/>
-          <a:lstStyle/>
-          <a:p>
-            <a:pPr algn="r" indent="0" marL="0">
+            <a:pPr algn="ctr" indent="0" marL="0">
               <a:buNone/>
             </a:pPr>
             <a:r>
               <a:rPr lang="en-US" sz="1200" b="1" dirty="0">
                 <a:solidFill>
-                  <a:schemeClr val="tx2"/>
-                </a:solidFill>
-                <a:latin typeface="Calibri" pitchFamily="34" charset="0"/>
-                <a:ea typeface="Calibri" pitchFamily="34" charset="-122"/>
-                <a:cs typeface="Calibri" pitchFamily="34" charset="-120"/>
-              </a:rPr>
-              <a:t>24 m</a:t>
+                  <a:schemeClr val="bg1"/>
+                </a:solidFill>
+                <a:latin typeface="Calibri" pitchFamily="34" charset="0"/>
+                <a:ea typeface="Calibri" pitchFamily="34" charset="-122"/>
+                <a:cs typeface="Calibri" pitchFamily="34" charset="-120"/>
+              </a:rPr>
+              <a:t>Amrit Sarovar</a:t>
             </a:r>
             <a:endParaRPr lang="en-US" sz="1200" dirty="0"/>
           </a:p>
@@ -6145,112 +6211,7 @@
       </p:sp>
       <p:sp>
         <p:nvSpPr>
-          <p:cNvPr id="129" name="Text 127"/>
-          <p:cNvSpPr txBox="1"/>
-          <p:nvPr/>
-        </p:nvSpPr>
-        <p:spPr>
-          <a:xfrm>
-            <a:off x="621792" y="2011680"/>
-            <a:ext cx="228600" cy="182880"/>
-          </a:xfrm>
-          <a:prstGeom prst="rect">
-            <a:avLst/>
-          </a:prstGeom>
-          <a:noFill/>
-          <a:ln/>
-        </p:spPr>
-        <p:txBody>
-          <a:bodyPr wrap="square" lIns="0" tIns="0" rIns="0" bIns="0" rtlCol="0" anchor="ctr"/>
-          <a:lstStyle/>
-          <a:p>
-            <a:pPr indent="0" marL="0">
-              <a:buNone/>
-            </a:pPr>
-            <a:r>
-              <a:rPr lang="en-US" sz="1000" dirty="0">
-                <a:solidFill>
-                  <a:srgbClr val="4A5A50"/>
-                </a:solidFill>
-                <a:latin typeface="Calibri" pitchFamily="34" charset="0"/>
-                <a:ea typeface="Calibri" pitchFamily="34" charset="-122"/>
-                <a:cs typeface="Calibri" pitchFamily="34" charset="-120"/>
-              </a:rPr>
-              <a:t>5 m</a:t>
-            </a:r>
-            <a:endParaRPr lang="en-US" sz="1000" dirty="0"/>
-          </a:p>
-        </p:txBody>
-      </p:sp>
-      <p:sp>
-        <p:nvSpPr>
-          <p:cNvPr id="130" name="Amrit Sarovar"/>
-          <p:cNvSpPr/>
-          <p:nvPr/>
-        </p:nvSpPr>
-        <p:spPr>
-          <a:xfrm>
-            <a:off x="10908792" y="2862072"/>
-            <a:ext cx="868680" cy="1005840"/>
-          </a:xfrm>
-          <a:prstGeom prst="roundRect">
-            <a:avLst>
-              <a:gd name="adj" fmla="val 12632"/>
-            </a:avLst>
-          </a:prstGeom>
-          <a:solidFill>
-            <a:schemeClr val="accent5"/>
-          </a:solidFill>
-          <a:ln w="12700">
-            <a:solidFill>
-              <a:schemeClr val="accent5"/>
-            </a:solidFill>
-            <a:prstDash val="solid"/>
-          </a:ln>
-        </p:spPr>
-      </p:sp>
-      <p:sp>
-        <p:nvSpPr>
           <p:cNvPr id="131" name="Text 129"/>
-          <p:cNvSpPr txBox="1"/>
-          <p:nvPr/>
-        </p:nvSpPr>
-        <p:spPr>
-          <a:xfrm>
-            <a:off x="10908792" y="2862072"/>
-            <a:ext cx="868680" cy="1005840"/>
-          </a:xfrm>
-          <a:prstGeom prst="rect">
-            <a:avLst/>
-          </a:prstGeom>
-          <a:noFill/>
-          <a:ln/>
-        </p:spPr>
-        <p:txBody>
-          <a:bodyPr wrap="square" lIns="0" tIns="0" rIns="0" bIns="0" rtlCol="0" anchor="ctr"/>
-          <a:lstStyle/>
-          <a:p>
-            <a:pPr algn="ctr" indent="0" marL="0">
-              <a:buNone/>
-            </a:pPr>
-            <a:r>
-              <a:rPr lang="en-US" sz="1200" b="1" dirty="0">
-                <a:solidFill>
-                  <a:schemeClr val="bg1"/>
-                </a:solidFill>
-                <a:latin typeface="Calibri" pitchFamily="34" charset="0"/>
-                <a:ea typeface="Calibri" pitchFamily="34" charset="-122"/>
-                <a:cs typeface="Calibri" pitchFamily="34" charset="-120"/>
-              </a:rPr>
-              <a:t>Amrit Sarovar</a:t>
-            </a:r>
-            <a:endParaRPr lang="en-US" sz="1200" dirty="0"/>
-          </a:p>
-        </p:txBody>
-      </p:sp>
-      <p:sp>
-        <p:nvSpPr>
-          <p:cNvPr id="132" name="Text 130"/>
           <p:cNvSpPr txBox="1"/>
           <p:nvPr/>
         </p:nvSpPr>

</xml_diff>